<commit_message>
fixed coding of Material
included coding of E.material into individual experiments, with 1 as default
</commit_message>
<xml_diff>
--- a/IMSim.Mediated.Results.pptx
+++ b/IMSim.Mediated.Results.pptx
@@ -86,6 +86,8 @@
     <p:sldId id="448" r:id="rId80"/>
     <p:sldId id="452" r:id="rId81"/>
     <p:sldId id="453" r:id="rId82"/>
+    <p:sldId id="454" r:id="rId83"/>
+    <p:sldId id="455" r:id="rId84"/>
   </p:sldIdLst>
   <p:sldSz cx="12192000" cy="6858000"/>
   <p:notesSz cx="6858000" cy="9144000"/>
@@ -10464,13 +10466,8 @@
             </a:r>
             <a:r>
               <a:rPr lang="en-CH" dirty="0"/>
-              <a:t> = 0.2 but not 0.1; 0.3 vs. 0.2 makes no </a:t>
-            </a:r>
-            <a:r>
-              <a:rPr lang="en-CH"/>
-              <a:t>discernible difference)</a:t>
-            </a:r>
-            <a:endParaRPr lang="en-CH" dirty="0"/>
+              <a:t> = 0.2 but not 0.1; 0.3 vs. 0.2 makes no discernible difference)</a:t>
+            </a:r>
           </a:p>
         </p:txBody>
       </p:sp>
@@ -10581,6 +10578,242 @@
     <p:extLst>
       <p:ext uri="{BB962C8B-B14F-4D97-AF65-F5344CB8AC3E}">
         <p14:creationId xmlns:p14="http://schemas.microsoft.com/office/powerpoint/2010/main" val="4056238010"/>
+      </p:ext>
+    </p:extLst>
+  </p:cSld>
+  <p:clrMapOvr>
+    <a:masterClrMapping/>
+  </p:clrMapOvr>
+</p:sld>
+</file>
+
+<file path=ppt/slides/slide82.xml><?xml version="1.0" encoding="utf-8"?>
+<p:sld xmlns:a="http://schemas.openxmlformats.org/drawingml/2006/main" xmlns:r="http://schemas.openxmlformats.org/officeDocument/2006/relationships" xmlns:p="http://schemas.openxmlformats.org/presentationml/2006/main">
+  <p:cSld>
+    <p:spTree>
+      <p:nvGrpSpPr>
+        <p:cNvPr id="1" name=""/>
+        <p:cNvGrpSpPr/>
+        <p:nvPr/>
+      </p:nvGrpSpPr>
+      <p:grpSpPr>
+        <a:xfrm>
+          <a:off x="0" y="0"/>
+          <a:ext cx="0" cy="0"/>
+          <a:chOff x="0" y="0"/>
+          <a:chExt cx="0" cy="0"/>
+        </a:xfrm>
+      </p:grpSpPr>
+      <p:pic>
+        <p:nvPicPr>
+          <p:cNvPr id="2" name="Picture 1">
+            <a:extLst>
+              <a:ext uri="{FF2B5EF4-FFF2-40B4-BE49-F238E27FC236}">
+                <a16:creationId xmlns:a16="http://schemas.microsoft.com/office/drawing/2014/main" id="{1FBF87ED-2E05-474D-0133-170575F56B1C}"/>
+              </a:ext>
+            </a:extLst>
+          </p:cNvPr>
+          <p:cNvPicPr>
+            <a:picLocks noChangeAspect="1"/>
+          </p:cNvPicPr>
+          <p:nvPr/>
+        </p:nvPicPr>
+        <p:blipFill>
+          <a:blip r:embed="rId2"/>
+          <a:stretch>
+            <a:fillRect/>
+          </a:stretch>
+        </p:blipFill>
+        <p:spPr>
+          <a:xfrm>
+            <a:off x="140545" y="655626"/>
+            <a:ext cx="5598511" cy="6164273"/>
+          </a:xfrm>
+          <a:prstGeom prst="rect">
+            <a:avLst/>
+          </a:prstGeom>
+        </p:spPr>
+      </p:pic>
+      <p:sp>
+        <p:nvSpPr>
+          <p:cNvPr id="3" name="TextBox 2">
+            <a:extLst>
+              <a:ext uri="{FF2B5EF4-FFF2-40B4-BE49-F238E27FC236}">
+                <a16:creationId xmlns:a16="http://schemas.microsoft.com/office/drawing/2014/main" id="{B33B1116-6768-3B37-7513-562E2D1D80E0}"/>
+              </a:ext>
+            </a:extLst>
+          </p:cNvPr>
+          <p:cNvSpPr txBox="1"/>
+          <p:nvPr/>
+        </p:nvSpPr>
+        <p:spPr>
+          <a:xfrm>
+            <a:off x="538843" y="324395"/>
+            <a:ext cx="3853543" cy="369332"/>
+          </a:xfrm>
+          <a:prstGeom prst="rect">
+            <a:avLst/>
+          </a:prstGeom>
+          <a:noFill/>
+        </p:spPr>
+        <p:txBody>
+          <a:bodyPr wrap="square" rtlCol="0">
+            <a:spAutoFit/>
+          </a:bodyPr>
+          <a:lstStyle/>
+          <a:p>
+            <a:r>
+              <a:rPr lang="en-CH" dirty="0"/>
+              <a:t>CD cueing (</a:t>
+            </a:r>
+            <a:r>
+              <a:rPr lang="en-CH" dirty="0" err="1"/>
+              <a:t>P.filter</a:t>
+            </a:r>
+            <a:r>
+              <a:rPr lang="en-CH" dirty="0"/>
+              <a:t> = 0.3)</a:t>
+            </a:r>
+          </a:p>
+        </p:txBody>
+      </p:sp>
+      <p:pic>
+        <p:nvPicPr>
+          <p:cNvPr id="4" name="Picture 3">
+            <a:extLst>
+              <a:ext uri="{FF2B5EF4-FFF2-40B4-BE49-F238E27FC236}">
+                <a16:creationId xmlns:a16="http://schemas.microsoft.com/office/drawing/2014/main" id="{FAD3A9B3-5BA8-B0C5-85CA-E608C74A8E35}"/>
+              </a:ext>
+            </a:extLst>
+          </p:cNvPr>
+          <p:cNvPicPr>
+            <a:picLocks noChangeAspect="1"/>
+          </p:cNvPicPr>
+          <p:nvPr/>
+        </p:nvPicPr>
+        <p:blipFill>
+          <a:blip r:embed="rId3"/>
+          <a:stretch>
+            <a:fillRect/>
+          </a:stretch>
+        </p:blipFill>
+        <p:spPr>
+          <a:xfrm>
+            <a:off x="5629295" y="776111"/>
+            <a:ext cx="6422160" cy="5652685"/>
+          </a:xfrm>
+          <a:prstGeom prst="rect">
+            <a:avLst/>
+          </a:prstGeom>
+        </p:spPr>
+      </p:pic>
+    </p:spTree>
+    <p:extLst>
+      <p:ext uri="{BB962C8B-B14F-4D97-AF65-F5344CB8AC3E}">
+        <p14:creationId xmlns:p14="http://schemas.microsoft.com/office/powerpoint/2010/main" val="292656557"/>
+      </p:ext>
+    </p:extLst>
+  </p:cSld>
+  <p:clrMapOvr>
+    <a:masterClrMapping/>
+  </p:clrMapOvr>
+</p:sld>
+</file>
+
+<file path=ppt/slides/slide83.xml><?xml version="1.0" encoding="utf-8"?>
+<p:sld xmlns:a="http://schemas.openxmlformats.org/drawingml/2006/main" xmlns:r="http://schemas.openxmlformats.org/officeDocument/2006/relationships" xmlns:p="http://schemas.openxmlformats.org/presentationml/2006/main">
+  <p:cSld>
+    <p:spTree>
+      <p:nvGrpSpPr>
+        <p:cNvPr id="1" name=""/>
+        <p:cNvGrpSpPr/>
+        <p:nvPr/>
+      </p:nvGrpSpPr>
+      <p:grpSpPr>
+        <a:xfrm>
+          <a:off x="0" y="0"/>
+          <a:ext cx="0" cy="0"/>
+          <a:chOff x="0" y="0"/>
+          <a:chExt cx="0" cy="0"/>
+        </a:xfrm>
+      </p:grpSpPr>
+      <p:pic>
+        <p:nvPicPr>
+          <p:cNvPr id="2" name="Picture 1">
+            <a:extLst>
+              <a:ext uri="{FF2B5EF4-FFF2-40B4-BE49-F238E27FC236}">
+                <a16:creationId xmlns:a16="http://schemas.microsoft.com/office/drawing/2014/main" id="{A5287E57-A4C0-3F70-38B9-A0810FB1D338}"/>
+              </a:ext>
+            </a:extLst>
+          </p:cNvPr>
+          <p:cNvPicPr>
+            <a:picLocks noChangeAspect="1"/>
+          </p:cNvPicPr>
+          <p:nvPr/>
+        </p:nvPicPr>
+        <p:blipFill>
+          <a:blip r:embed="rId2"/>
+          <a:stretch>
+            <a:fillRect/>
+          </a:stretch>
+        </p:blipFill>
+        <p:spPr>
+          <a:xfrm>
+            <a:off x="2938002" y="332014"/>
+            <a:ext cx="8142710" cy="6193971"/>
+          </a:xfrm>
+          <a:prstGeom prst="rect">
+            <a:avLst/>
+          </a:prstGeom>
+        </p:spPr>
+      </p:pic>
+      <p:sp>
+        <p:nvSpPr>
+          <p:cNvPr id="3" name="TextBox 2">
+            <a:extLst>
+              <a:ext uri="{FF2B5EF4-FFF2-40B4-BE49-F238E27FC236}">
+                <a16:creationId xmlns:a16="http://schemas.microsoft.com/office/drawing/2014/main" id="{C05AE1E3-B7E2-01CC-BC53-858496FE7A51}"/>
+              </a:ext>
+            </a:extLst>
+          </p:cNvPr>
+          <p:cNvSpPr txBox="1"/>
+          <p:nvPr/>
+        </p:nvSpPr>
+        <p:spPr>
+          <a:xfrm>
+            <a:off x="538844" y="324395"/>
+            <a:ext cx="2563586" cy="369332"/>
+          </a:xfrm>
+          <a:prstGeom prst="rect">
+            <a:avLst/>
+          </a:prstGeom>
+          <a:noFill/>
+        </p:spPr>
+        <p:txBody>
+          <a:bodyPr wrap="square" rtlCol="0">
+            <a:spAutoFit/>
+          </a:bodyPr>
+          <a:lstStyle/>
+          <a:p>
+            <a:r>
+              <a:rPr lang="en-CH"/>
+              <a:t>Refreshing (</a:t>
+            </a:r>
+            <a:r>
+              <a:rPr lang="en-CH" dirty="0" err="1"/>
+              <a:t>P.filter</a:t>
+            </a:r>
+            <a:r>
+              <a:rPr lang="en-CH" dirty="0"/>
+              <a:t> = 0.3)</a:t>
+            </a:r>
+          </a:p>
+        </p:txBody>
+      </p:sp>
+    </p:spTree>
+    <p:extLst>
+      <p:ext uri="{BB962C8B-B14F-4D97-AF65-F5344CB8AC3E}">
+        <p14:creationId xmlns:p14="http://schemas.microsoft.com/office/powerpoint/2010/main" val="984235077"/>
       </p:ext>
     </p:extLst>
   </p:cSld>

</xml_diff>

<commit_message>
Fixed error in TwoArrayISI
</commit_message>
<xml_diff>
--- a/IMSim.Mediated.Results.pptx
+++ b/IMSim.Mediated.Results.pptx
@@ -88,6 +88,8 @@
     <p:sldId id="453" r:id="rId82"/>
     <p:sldId id="454" r:id="rId83"/>
     <p:sldId id="455" r:id="rId84"/>
+    <p:sldId id="456" r:id="rId85"/>
+    <p:sldId id="457" r:id="rId86"/>
   </p:sldIdLst>
   <p:sldSz cx="12192000" cy="6858000"/>
   <p:notesSz cx="6858000" cy="9144000"/>
@@ -10796,7 +10798,7 @@
           <a:lstStyle/>
           <a:p>
             <a:r>
-              <a:rPr lang="en-CH"/>
+              <a:rPr lang="en-CH" dirty="0"/>
               <a:t>Refreshing (</a:t>
             </a:r>
             <a:r>
@@ -10814,6 +10816,169 @@
     <p:extLst>
       <p:ext uri="{BB962C8B-B14F-4D97-AF65-F5344CB8AC3E}">
         <p14:creationId xmlns:p14="http://schemas.microsoft.com/office/powerpoint/2010/main" val="984235077"/>
+      </p:ext>
+    </p:extLst>
+  </p:cSld>
+  <p:clrMapOvr>
+    <a:masterClrMapping/>
+  </p:clrMapOvr>
+</p:sld>
+</file>
+
+<file path=ppt/slides/slide84.xml><?xml version="1.0" encoding="utf-8"?>
+<p:sld xmlns:a="http://schemas.openxmlformats.org/drawingml/2006/main" xmlns:r="http://schemas.openxmlformats.org/officeDocument/2006/relationships" xmlns:p="http://schemas.openxmlformats.org/presentationml/2006/main">
+  <p:cSld>
+    <p:spTree>
+      <p:nvGrpSpPr>
+        <p:cNvPr id="1" name=""/>
+        <p:cNvGrpSpPr/>
+        <p:nvPr/>
+      </p:nvGrpSpPr>
+      <p:grpSpPr>
+        <a:xfrm>
+          <a:off x="0" y="0"/>
+          <a:ext cx="0" cy="0"/>
+          <a:chOff x="0" y="0"/>
+          <a:chExt cx="0" cy="0"/>
+        </a:xfrm>
+      </p:grpSpPr>
+      <p:pic>
+        <p:nvPicPr>
+          <p:cNvPr id="2" name="Picture 1">
+            <a:extLst>
+              <a:ext uri="{FF2B5EF4-FFF2-40B4-BE49-F238E27FC236}">
+                <a16:creationId xmlns:a16="http://schemas.microsoft.com/office/drawing/2014/main" id="{BF38A349-C698-63CB-6E36-CCC252473225}"/>
+              </a:ext>
+            </a:extLst>
+          </p:cNvPr>
+          <p:cNvPicPr>
+            <a:picLocks noChangeAspect="1"/>
+          </p:cNvPicPr>
+          <p:nvPr/>
+        </p:nvPicPr>
+        <p:blipFill>
+          <a:blip r:embed="rId2"/>
+          <a:stretch>
+            <a:fillRect/>
+          </a:stretch>
+        </p:blipFill>
+        <p:spPr>
+          <a:xfrm>
+            <a:off x="2332429" y="0"/>
+            <a:ext cx="9464798" cy="6858000"/>
+          </a:xfrm>
+          <a:prstGeom prst="rect">
+            <a:avLst/>
+          </a:prstGeom>
+        </p:spPr>
+      </p:pic>
+      <p:sp>
+        <p:nvSpPr>
+          <p:cNvPr id="3" name="TextBox 2">
+            <a:extLst>
+              <a:ext uri="{FF2B5EF4-FFF2-40B4-BE49-F238E27FC236}">
+                <a16:creationId xmlns:a16="http://schemas.microsoft.com/office/drawing/2014/main" id="{A12B027F-7761-F3A7-1328-804A84C2B602}"/>
+              </a:ext>
+            </a:extLst>
+          </p:cNvPr>
+          <p:cNvSpPr txBox="1"/>
+          <p:nvPr/>
+        </p:nvSpPr>
+        <p:spPr>
+          <a:xfrm>
+            <a:off x="478972" y="810986"/>
+            <a:ext cx="1812472" cy="923330"/>
+          </a:xfrm>
+          <a:prstGeom prst="rect">
+            <a:avLst/>
+          </a:prstGeom>
+          <a:noFill/>
+        </p:spPr>
+        <p:txBody>
+          <a:bodyPr wrap="square" rtlCol="0">
+            <a:spAutoFit/>
+          </a:bodyPr>
+          <a:lstStyle/>
+          <a:p>
+            <a:r>
+              <a:rPr lang="en-CH" dirty="0"/>
+              <a:t>Prolific, </a:t>
+            </a:r>
+            <a:r>
+              <a:rPr lang="en-CH" dirty="0" err="1"/>
+              <a:t>cStrength</a:t>
+            </a:r>
+            <a:r>
+              <a:rPr lang="en-CH" dirty="0"/>
+              <a:t> reduced to 0.6</a:t>
+            </a:r>
+          </a:p>
+        </p:txBody>
+      </p:sp>
+    </p:spTree>
+    <p:extLst>
+      <p:ext uri="{BB962C8B-B14F-4D97-AF65-F5344CB8AC3E}">
+        <p14:creationId xmlns:p14="http://schemas.microsoft.com/office/powerpoint/2010/main" val="1815074279"/>
+      </p:ext>
+    </p:extLst>
+  </p:cSld>
+  <p:clrMapOvr>
+    <a:masterClrMapping/>
+  </p:clrMapOvr>
+</p:sld>
+</file>
+
+<file path=ppt/slides/slide85.xml><?xml version="1.0" encoding="utf-8"?>
+<p:sld xmlns:a="http://schemas.openxmlformats.org/drawingml/2006/main" xmlns:r="http://schemas.openxmlformats.org/officeDocument/2006/relationships" xmlns:p="http://schemas.openxmlformats.org/presentationml/2006/main">
+  <p:cSld>
+    <p:spTree>
+      <p:nvGrpSpPr>
+        <p:cNvPr id="1" name=""/>
+        <p:cNvGrpSpPr/>
+        <p:nvPr/>
+      </p:nvGrpSpPr>
+      <p:grpSpPr>
+        <a:xfrm>
+          <a:off x="0" y="0"/>
+          <a:ext cx="0" cy="0"/>
+          <a:chOff x="0" y="0"/>
+          <a:chExt cx="0" cy="0"/>
+        </a:xfrm>
+      </p:grpSpPr>
+      <p:pic>
+        <p:nvPicPr>
+          <p:cNvPr id="2" name="Picture 1">
+            <a:extLst>
+              <a:ext uri="{FF2B5EF4-FFF2-40B4-BE49-F238E27FC236}">
+                <a16:creationId xmlns:a16="http://schemas.microsoft.com/office/drawing/2014/main" id="{7DB71F2A-A8E9-00E0-AA6B-63127D5B3026}"/>
+              </a:ext>
+            </a:extLst>
+          </p:cNvPr>
+          <p:cNvPicPr>
+            <a:picLocks noChangeAspect="1"/>
+          </p:cNvPicPr>
+          <p:nvPr/>
+        </p:nvPicPr>
+        <p:blipFill>
+          <a:blip r:embed="rId2"/>
+          <a:stretch>
+            <a:fillRect/>
+          </a:stretch>
+        </p:blipFill>
+        <p:spPr>
+          <a:xfrm>
+            <a:off x="1838809" y="0"/>
+            <a:ext cx="8514381" cy="6858000"/>
+          </a:xfrm>
+          <a:prstGeom prst="rect">
+            <a:avLst/>
+          </a:prstGeom>
+        </p:spPr>
+      </p:pic>
+    </p:spTree>
+    <p:extLst>
+      <p:ext uri="{BB962C8B-B14F-4D97-AF65-F5344CB8AC3E}">
+        <p14:creationId xmlns:p14="http://schemas.microsoft.com/office/powerpoint/2010/main" val="2247015041"/>
       </p:ext>
     </p:extLst>
   </p:cSld>

</xml_diff>

<commit_message>
fixed another bug in RetroCueSepMech
</commit_message>
<xml_diff>
--- a/IMSim.Mediated.Results.pptx
+++ b/IMSim.Mediated.Results.pptx
@@ -90,6 +90,7 @@
     <p:sldId id="455" r:id="rId84"/>
     <p:sldId id="456" r:id="rId85"/>
     <p:sldId id="457" r:id="rId86"/>
+    <p:sldId id="458" r:id="rId87"/>
   </p:sldIdLst>
   <p:sldSz cx="12192000" cy="6858000"/>
   <p:notesSz cx="6858000" cy="9144000"/>
@@ -10988,6 +10989,66 @@
 </p:sld>
 </file>
 
+<file path=ppt/slides/slide86.xml><?xml version="1.0" encoding="utf-8"?>
+<p:sld xmlns:a="http://schemas.openxmlformats.org/drawingml/2006/main" xmlns:r="http://schemas.openxmlformats.org/officeDocument/2006/relationships" xmlns:p="http://schemas.openxmlformats.org/presentationml/2006/main">
+  <p:cSld>
+    <p:spTree>
+      <p:nvGrpSpPr>
+        <p:cNvPr id="1" name=""/>
+        <p:cNvGrpSpPr/>
+        <p:nvPr/>
+      </p:nvGrpSpPr>
+      <p:grpSpPr>
+        <a:xfrm>
+          <a:off x="0" y="0"/>
+          <a:ext cx="0" cy="0"/>
+          <a:chOff x="0" y="0"/>
+          <a:chExt cx="0" cy="0"/>
+        </a:xfrm>
+      </p:grpSpPr>
+      <p:pic>
+        <p:nvPicPr>
+          <p:cNvPr id="2" name="Picture 1">
+            <a:extLst>
+              <a:ext uri="{FF2B5EF4-FFF2-40B4-BE49-F238E27FC236}">
+                <a16:creationId xmlns:a16="http://schemas.microsoft.com/office/drawing/2014/main" id="{A359A6B3-8268-FD0E-4227-DDF95EF53AFA}"/>
+              </a:ext>
+            </a:extLst>
+          </p:cNvPr>
+          <p:cNvPicPr>
+            <a:picLocks noChangeAspect="1"/>
+          </p:cNvPicPr>
+          <p:nvPr/>
+        </p:nvPicPr>
+        <p:blipFill>
+          <a:blip r:embed="rId2"/>
+          <a:stretch>
+            <a:fillRect/>
+          </a:stretch>
+        </p:blipFill>
+        <p:spPr>
+          <a:xfrm>
+            <a:off x="2596839" y="0"/>
+            <a:ext cx="6878579" cy="6858000"/>
+          </a:xfrm>
+          <a:prstGeom prst="rect">
+            <a:avLst/>
+          </a:prstGeom>
+        </p:spPr>
+      </p:pic>
+    </p:spTree>
+    <p:extLst>
+      <p:ext uri="{BB962C8B-B14F-4D97-AF65-F5344CB8AC3E}">
+        <p14:creationId xmlns:p14="http://schemas.microsoft.com/office/powerpoint/2010/main" val="3030151035"/>
+      </p:ext>
+    </p:extLst>
+  </p:cSld>
+  <p:clrMapOvr>
+    <a:masterClrMapping/>
+  </p:clrMapOvr>
+</p:sld>
+</file>
+
 <file path=ppt/slides/slide9.xml><?xml version="1.0" encoding="utf-8"?>
 <p:sld xmlns:a="http://schemas.openxmlformats.org/drawingml/2006/main" xmlns:r="http://schemas.openxmlformats.org/officeDocument/2006/relationships" xmlns:p="http://schemas.openxmlformats.org/presentationml/2006/main">
   <p:cSld>

</xml_diff>

<commit_message>
Changed IEM training in SetsizeTrackNeuralSignals
IEM training is now separately for each time point as in Foster et al. (2017)
</commit_message>
<xml_diff>
--- a/IMSim.Mediated.Results.pptx
+++ b/IMSim.Mediated.Results.pptx
@@ -91,6 +91,7 @@
     <p:sldId id="456" r:id="rId85"/>
     <p:sldId id="457" r:id="rId86"/>
     <p:sldId id="458" r:id="rId87"/>
+    <p:sldId id="459" r:id="rId88"/>
   </p:sldIdLst>
   <p:sldSz cx="12192000" cy="6858000"/>
   <p:notesSz cx="6858000" cy="9144000"/>
@@ -11028,8 +11029,38 @@
         </p:blipFill>
         <p:spPr>
           <a:xfrm>
-            <a:off x="2596839" y="0"/>
-            <a:ext cx="6878579" cy="6858000"/>
+            <a:off x="0" y="81643"/>
+            <a:ext cx="6501895" cy="6482443"/>
+          </a:xfrm>
+          <a:prstGeom prst="rect">
+            <a:avLst/>
+          </a:prstGeom>
+        </p:spPr>
+      </p:pic>
+      <p:pic>
+        <p:nvPicPr>
+          <p:cNvPr id="4" name="Picture 3">
+            <a:extLst>
+              <a:ext uri="{FF2B5EF4-FFF2-40B4-BE49-F238E27FC236}">
+                <a16:creationId xmlns:a16="http://schemas.microsoft.com/office/drawing/2014/main" id="{A34CBC49-F63E-3ECC-77A1-BDDF0EFFA968}"/>
+              </a:ext>
+            </a:extLst>
+          </p:cNvPr>
+          <p:cNvPicPr>
+            <a:picLocks noChangeAspect="1"/>
+          </p:cNvPicPr>
+          <p:nvPr/>
+        </p:nvPicPr>
+        <p:blipFill>
+          <a:blip r:embed="rId3"/>
+          <a:stretch>
+            <a:fillRect/>
+          </a:stretch>
+        </p:blipFill>
+        <p:spPr>
+          <a:xfrm>
+            <a:off x="5999713" y="141514"/>
+            <a:ext cx="6318724" cy="6716486"/>
           </a:xfrm>
           <a:prstGeom prst="rect">
             <a:avLst/>
@@ -11040,6 +11071,96 @@
     <p:extLst>
       <p:ext uri="{BB962C8B-B14F-4D97-AF65-F5344CB8AC3E}">
         <p14:creationId xmlns:p14="http://schemas.microsoft.com/office/powerpoint/2010/main" val="3030151035"/>
+      </p:ext>
+    </p:extLst>
+  </p:cSld>
+  <p:clrMapOvr>
+    <a:masterClrMapping/>
+  </p:clrMapOvr>
+</p:sld>
+</file>
+
+<file path=ppt/slides/slide87.xml><?xml version="1.0" encoding="utf-8"?>
+<p:sld xmlns:a="http://schemas.openxmlformats.org/drawingml/2006/main" xmlns:r="http://schemas.openxmlformats.org/officeDocument/2006/relationships" xmlns:p="http://schemas.openxmlformats.org/presentationml/2006/main">
+  <p:cSld>
+    <p:spTree>
+      <p:nvGrpSpPr>
+        <p:cNvPr id="1" name=""/>
+        <p:cNvGrpSpPr/>
+        <p:nvPr/>
+      </p:nvGrpSpPr>
+      <p:grpSpPr>
+        <a:xfrm>
+          <a:off x="0" y="0"/>
+          <a:ext cx="0" cy="0"/>
+          <a:chOff x="0" y="0"/>
+          <a:chExt cx="0" cy="0"/>
+        </a:xfrm>
+      </p:grpSpPr>
+      <p:pic>
+        <p:nvPicPr>
+          <p:cNvPr id="2" name="Picture 1">
+            <a:extLst>
+              <a:ext uri="{FF2B5EF4-FFF2-40B4-BE49-F238E27FC236}">
+                <a16:creationId xmlns:a16="http://schemas.microsoft.com/office/drawing/2014/main" id="{0C2D68C5-8562-6386-2C2A-5D5C82DD233C}"/>
+              </a:ext>
+            </a:extLst>
+          </p:cNvPr>
+          <p:cNvPicPr>
+            <a:picLocks noChangeAspect="1"/>
+          </p:cNvPicPr>
+          <p:nvPr/>
+        </p:nvPicPr>
+        <p:blipFill>
+          <a:blip r:embed="rId2"/>
+          <a:stretch>
+            <a:fillRect/>
+          </a:stretch>
+        </p:blipFill>
+        <p:spPr>
+          <a:xfrm>
+            <a:off x="5921829" y="38100"/>
+            <a:ext cx="6270171" cy="6858000"/>
+          </a:xfrm>
+          <a:prstGeom prst="rect">
+            <a:avLst/>
+          </a:prstGeom>
+        </p:spPr>
+      </p:pic>
+      <p:pic>
+        <p:nvPicPr>
+          <p:cNvPr id="3" name="Picture 2">
+            <a:extLst>
+              <a:ext uri="{FF2B5EF4-FFF2-40B4-BE49-F238E27FC236}">
+                <a16:creationId xmlns:a16="http://schemas.microsoft.com/office/drawing/2014/main" id="{593A6A9B-B339-A1ED-8C02-9249BC4F985B}"/>
+              </a:ext>
+            </a:extLst>
+          </p:cNvPr>
+          <p:cNvPicPr>
+            <a:picLocks noChangeAspect="1"/>
+          </p:cNvPicPr>
+          <p:nvPr/>
+        </p:nvPicPr>
+        <p:blipFill>
+          <a:blip r:embed="rId3"/>
+          <a:stretch>
+            <a:fillRect/>
+          </a:stretch>
+        </p:blipFill>
+        <p:spPr>
+          <a:xfrm>
+            <a:off x="-63359" y="195942"/>
+            <a:ext cx="6159359" cy="5949043"/>
+          </a:xfrm>
+          <a:prstGeom prst="rect">
+            <a:avLst/>
+          </a:prstGeom>
+        </p:spPr>
+      </p:pic>
+    </p:spTree>
+    <p:extLst>
+      <p:ext uri="{BB962C8B-B14F-4D97-AF65-F5344CB8AC3E}">
+        <p14:creationId xmlns:p14="http://schemas.microsoft.com/office/powerpoint/2010/main" val="2154078622"/>
       </p:ext>
     </p:extLst>
   </p:cSld>

</xml_diff>

<commit_message>
Added diagnostics to TwoArrayISI
</commit_message>
<xml_diff>
--- a/IMSim.Mediated.Results.pptx
+++ b/IMSim.Mediated.Results.pptx
@@ -92,6 +92,8 @@
     <p:sldId id="457" r:id="rId86"/>
     <p:sldId id="458" r:id="rId87"/>
     <p:sldId id="459" r:id="rId88"/>
+    <p:sldId id="460" r:id="rId89"/>
+    <p:sldId id="461" r:id="rId90"/>
   </p:sldIdLst>
   <p:sldSz cx="12192000" cy="6858000"/>
   <p:notesSz cx="6858000" cy="9144000"/>
@@ -11170,6 +11172,126 @@
 </p:sld>
 </file>
 
+<file path=ppt/slides/slide88.xml><?xml version="1.0" encoding="utf-8"?>
+<p:sld xmlns:a="http://schemas.openxmlformats.org/drawingml/2006/main" xmlns:r="http://schemas.openxmlformats.org/officeDocument/2006/relationships" xmlns:p="http://schemas.openxmlformats.org/presentationml/2006/main">
+  <p:cSld>
+    <p:spTree>
+      <p:nvGrpSpPr>
+        <p:cNvPr id="1" name=""/>
+        <p:cNvGrpSpPr/>
+        <p:nvPr/>
+      </p:nvGrpSpPr>
+      <p:grpSpPr>
+        <a:xfrm>
+          <a:off x="0" y="0"/>
+          <a:ext cx="0" cy="0"/>
+          <a:chOff x="0" y="0"/>
+          <a:chExt cx="0" cy="0"/>
+        </a:xfrm>
+      </p:grpSpPr>
+      <p:pic>
+        <p:nvPicPr>
+          <p:cNvPr id="2" name="Picture 1">
+            <a:extLst>
+              <a:ext uri="{FF2B5EF4-FFF2-40B4-BE49-F238E27FC236}">
+                <a16:creationId xmlns:a16="http://schemas.microsoft.com/office/drawing/2014/main" id="{2E7D8038-E0C5-E2A8-22E1-E052F7B7C560}"/>
+              </a:ext>
+            </a:extLst>
+          </p:cNvPr>
+          <p:cNvPicPr>
+            <a:picLocks noChangeAspect="1"/>
+          </p:cNvPicPr>
+          <p:nvPr/>
+        </p:nvPicPr>
+        <p:blipFill>
+          <a:blip r:embed="rId2"/>
+          <a:stretch>
+            <a:fillRect/>
+          </a:stretch>
+        </p:blipFill>
+        <p:spPr>
+          <a:xfrm>
+            <a:off x="0" y="84666"/>
+            <a:ext cx="12192000" cy="6688667"/>
+          </a:xfrm>
+          <a:prstGeom prst="rect">
+            <a:avLst/>
+          </a:prstGeom>
+        </p:spPr>
+      </p:pic>
+    </p:spTree>
+    <p:extLst>
+      <p:ext uri="{BB962C8B-B14F-4D97-AF65-F5344CB8AC3E}">
+        <p14:creationId xmlns:p14="http://schemas.microsoft.com/office/powerpoint/2010/main" val="4037625528"/>
+      </p:ext>
+    </p:extLst>
+  </p:cSld>
+  <p:clrMapOvr>
+    <a:masterClrMapping/>
+  </p:clrMapOvr>
+</p:sld>
+</file>
+
+<file path=ppt/slides/slide89.xml><?xml version="1.0" encoding="utf-8"?>
+<p:sld xmlns:a="http://schemas.openxmlformats.org/drawingml/2006/main" xmlns:r="http://schemas.openxmlformats.org/officeDocument/2006/relationships" xmlns:p="http://schemas.openxmlformats.org/presentationml/2006/main">
+  <p:cSld>
+    <p:spTree>
+      <p:nvGrpSpPr>
+        <p:cNvPr id="1" name=""/>
+        <p:cNvGrpSpPr/>
+        <p:nvPr/>
+      </p:nvGrpSpPr>
+      <p:grpSpPr>
+        <a:xfrm>
+          <a:off x="0" y="0"/>
+          <a:ext cx="0" cy="0"/>
+          <a:chOff x="0" y="0"/>
+          <a:chExt cx="0" cy="0"/>
+        </a:xfrm>
+      </p:grpSpPr>
+      <p:pic>
+        <p:nvPicPr>
+          <p:cNvPr id="2" name="Picture 1">
+            <a:extLst>
+              <a:ext uri="{FF2B5EF4-FFF2-40B4-BE49-F238E27FC236}">
+                <a16:creationId xmlns:a16="http://schemas.microsoft.com/office/drawing/2014/main" id="{073CBCE7-C49C-DB87-A9E9-6485DBAB0910}"/>
+              </a:ext>
+            </a:extLst>
+          </p:cNvPr>
+          <p:cNvPicPr>
+            <a:picLocks noChangeAspect="1"/>
+          </p:cNvPicPr>
+          <p:nvPr/>
+        </p:nvPicPr>
+        <p:blipFill>
+          <a:blip r:embed="rId2"/>
+          <a:stretch>
+            <a:fillRect/>
+          </a:stretch>
+        </p:blipFill>
+        <p:spPr>
+          <a:xfrm>
+            <a:off x="0" y="84666"/>
+            <a:ext cx="12192000" cy="6688667"/>
+          </a:xfrm>
+          <a:prstGeom prst="rect">
+            <a:avLst/>
+          </a:prstGeom>
+        </p:spPr>
+      </p:pic>
+    </p:spTree>
+    <p:extLst>
+      <p:ext uri="{BB962C8B-B14F-4D97-AF65-F5344CB8AC3E}">
+        <p14:creationId xmlns:p14="http://schemas.microsoft.com/office/powerpoint/2010/main" val="664266787"/>
+      </p:ext>
+    </p:extLst>
+  </p:cSld>
+  <p:clrMapOvr>
+    <a:masterClrMapping/>
+  </p:clrMapOvr>
+</p:sld>
+</file>
+
 <file path=ppt/slides/slide9.xml><?xml version="1.0" encoding="utf-8"?>
 <p:sld xmlns:a="http://schemas.openxmlformats.org/drawingml/2006/main" xmlns:r="http://schemas.openxmlformats.org/officeDocument/2006/relationships" xmlns:p="http://schemas.openxmlformats.org/presentationml/2006/main">
   <p:cSld>

</xml_diff>